<commit_message>
Update project team details and improve README
</commit_message>
<xml_diff>
--- a/deliverables/presentation/HTTP11_Web_Server_Project_Presentation.pptx
+++ b/deliverables/presentation/HTTP11_Web_Server_Project_Presentation.pptx
@@ -519,7 +519,7 @@
           <a:lstStyle/>
           <a:p>
             <a:r>
-              <a:t>Welcome committee members. Today I present the design, low-level implementation, and empirical verification of a multi-threaded HTTP/1.1 web server built strictly from scratch in ISO C17 on raw POSIX sockets without external libraries.</a:t>
+              <a:t>Welcome committee members and faculty evaluators. Today Yash Pradhan (24BCE0702) and Anjini Pandey (24BCE0714) present the design, low-level systems implementation, and empirical verification of a multi-threaded HTTP/1.1 web server built strictly from scratch in ISO C17 on raw POSIX sockets without external libraries.</a:t>
             </a:r>
           </a:p>
         </p:txBody>
@@ -4836,6 +4836,9 @@
           </a:p>
           <a:p>
             <a:pPr>
+              <a:spcAft>
+                <a:spcPts val="600"/>
+              </a:spcAft>
               <a:defRPr sz="1200" b="1">
                 <a:solidFill>
                   <a:srgbClr val="F8FAFC"/>
@@ -4843,19 +4846,19 @@
               </a:defRPr>
             </a:pPr>
             <a:r>
-              <a:t>Author: Systems Engineering Team   |   Course: Computer Networks (CS-504)   |   Date: October 2026</a:t>
+              <a:t>Project Team: 24BCE0702 - Yash Pradhan   |   24BCE0714 - Anjini Pandey</a:t>
             </a:r>
           </a:p>
           <a:p>
             <a:pPr>
-              <a:defRPr sz="1100">
+              <a:defRPr sz="1050">
                 <a:solidFill>
                   <a:srgbClr val="94A3B8"/>
                 </a:solidFill>
               </a:defRPr>
             </a:pPr>
             <a:r>
-              <a:t>Platform: Linux Kernel 6.6 / x86_64   |   Standards: RFC 9112, RFC 9110, POSIX.1-2008</a:t>
+              <a:t>Course: Computer Networks Lab (BCSE308P / CS-504)   |   Date: October 2026   |   Platform: Linux x86_64</a:t>
             </a:r>
           </a:p>
         </p:txBody>

</xml_diff>